<commit_message>
osworld: fix g9 replication bug, add closed-book/verify-replan harness, rerun affected sonnet5 tasks
Fixes a bug affecting g9 replication validity in osworld_eval.py and reruns
the subset of sonnet5 and verify-replan tasks affected by the fix and by
infra/rate-limit failures (113 of 303 task directories touched; legacy
pre-fix runs kept alongside for comparison). Adds the closed-book runner
and the codex_loop core module with tests, plus integration plans for the
longhorizon and verify-replan harnesses.
</commit_message>
<xml_diff>
--- a/benchmarks/osworld/results/agent_computer_sonnet5/a434992a-89df-4577-925c-0c58b747f0f4/run_1/16_2.pptx
+++ b/benchmarks/osworld/results/agent_computer_sonnet5/a434992a-89df-4577-925c-0c58b747f0f4/run_1/16_2.pptx
@@ -36,7 +36,7 @@
             <a:spLocks noGrp="1"/>
           </p:cNvSpPr>
           <p:nvPr>
-            <p:ph type="ftr" idx="2"/>
+            <p:ph type="ftr" idx="1"/>
           </p:nvPr>
         </p:nvSpPr>
         <p:spPr/>
@@ -56,14 +56,14 @@
             <a:spLocks noGrp="1"/>
           </p:cNvSpPr>
           <p:nvPr>
-            <p:ph type="sldNum" idx="3"/>
-          </p:nvPr>
-        </p:nvSpPr>
-        <p:spPr/>
-        <p:txBody>
-          <a:bodyPr/>
-          <a:p>
-            <a:fld id="{B5FA8615-6C14-41B4-B5CE-66210BDEC5C9}" type="slidenum">
+            <p:ph type="sldNum" idx="2"/>
+          </p:nvPr>
+        </p:nvSpPr>
+        <p:spPr/>
+        <p:txBody>
+          <a:bodyPr/>
+          <a:p>
+            <a:fld id="{102CDD73-E221-44D9-97A6-EC8B938A3181}" type="slidenum">
               <a:t>&lt;#&gt;</a:t>
             </a:fld>
           </a:p>
@@ -76,15 +76,15 @@
             <a:spLocks noGrp="1"/>
           </p:cNvSpPr>
           <p:nvPr>
-            <p:ph type="dt" idx="1"/>
-          </p:nvPr>
-        </p:nvSpPr>
-        <p:spPr/>
-        <p:txBody>
-          <a:bodyPr/>
-          <a:p>
-            <a:r>
-              <a:rPr lang="en-HK"/>
+            <p:ph type="dt" idx="3"/>
+          </p:nvPr>
+        </p:nvSpPr>
+        <p:spPr/>
+        <p:txBody>
+          <a:bodyPr/>
+          <a:p>
+            <a:r>
+              <a:rPr lang="en-US"/>
               <a:t/>
             </a:r>
           </a:p>
@@ -124,8 +124,8 @@
         </p:nvSpPr>
         <p:spPr>
           <a:xfrm>
-            <a:off x="457200" y="274680"/>
-            <a:ext cx="8229240" cy="1142640"/>
+            <a:off x="457200" y="273600"/>
+            <a:ext cx="8229240" cy="1144800"/>
           </a:xfrm>
           <a:prstGeom prst="rect">
             <a:avLst/>
@@ -140,11 +140,11 @@
             <a:noAutofit/>
           </a:bodyPr>
           <a:p>
-            <a:endParaRPr b="0" lang="en-US" sz="1800" spc="-1" strike="noStrike">
-              <a:solidFill>
-                <a:srgbClr val="000000"/>
-              </a:solidFill>
-              <a:latin typeface="Calibri"/>
+            <a:pPr algn="ctr">
+              <a:buNone/>
+            </a:pPr>
+            <a:endParaRPr b="0" lang="en-US" sz="4400" spc="-1" strike="noStrike">
+              <a:latin typeface="Arial"/>
             </a:endParaRPr>
           </a:p>
         </p:txBody>
@@ -161,8 +161,8 @@
         </p:nvSpPr>
         <p:spPr>
           <a:xfrm>
-            <a:off x="457200" y="1600200"/>
-            <a:ext cx="8229240" cy="2158560"/>
+            <a:off x="457200" y="1604520"/>
+            <a:ext cx="8229240" cy="1896840"/>
           </a:xfrm>
           <a:prstGeom prst="rect">
             <a:avLst/>
@@ -178,10 +178,7 @@
           </a:bodyPr>
           <a:p>
             <a:endParaRPr b="0" lang="en-US" sz="3200" spc="-1" strike="noStrike">
-              <a:solidFill>
-                <a:srgbClr val="000000"/>
-              </a:solidFill>
-              <a:latin typeface="Calibri"/>
+              <a:latin typeface="Arial"/>
             </a:endParaRPr>
           </a:p>
         </p:txBody>
@@ -198,8 +195,8 @@
         </p:nvSpPr>
         <p:spPr>
           <a:xfrm>
-            <a:off x="457200" y="3964320"/>
-            <a:ext cx="8229240" cy="2158560"/>
+            <a:off x="457200" y="3682080"/>
+            <a:ext cx="8229240" cy="1896840"/>
           </a:xfrm>
           <a:prstGeom prst="rect">
             <a:avLst/>
@@ -215,10 +212,7 @@
           </a:bodyPr>
           <a:p>
             <a:endParaRPr b="0" lang="en-US" sz="3200" spc="-1" strike="noStrike">
-              <a:solidFill>
-                <a:srgbClr val="000000"/>
-              </a:solidFill>
-              <a:latin typeface="Calibri"/>
+              <a:latin typeface="Arial"/>
             </a:endParaRPr>
           </a:p>
         </p:txBody>
@@ -230,7 +224,7 @@
             <a:spLocks noGrp="1"/>
           </p:cNvSpPr>
           <p:nvPr>
-            <p:ph type="ftr" idx="2"/>
+            <p:ph type="ftr" idx="1"/>
           </p:nvPr>
         </p:nvSpPr>
         <p:spPr/>
@@ -250,14 +244,14 @@
             <a:spLocks noGrp="1"/>
           </p:cNvSpPr>
           <p:nvPr>
-            <p:ph type="sldNum" idx="3"/>
-          </p:nvPr>
-        </p:nvSpPr>
-        <p:spPr/>
-        <p:txBody>
-          <a:bodyPr/>
-          <a:p>
-            <a:fld id="{E6109F24-DE9D-4BA6-9DF3-E0DD85F0E8BD}" type="slidenum">
+            <p:ph type="sldNum" idx="2"/>
+          </p:nvPr>
+        </p:nvSpPr>
+        <p:spPr/>
+        <p:txBody>
+          <a:bodyPr/>
+          <a:p>
+            <a:fld id="{83A61FC7-157D-435D-83E6-4303EB399C71}" type="slidenum">
               <a:t>&lt;#&gt;</a:t>
             </a:fld>
           </a:p>
@@ -270,15 +264,15 @@
             <a:spLocks noGrp="1"/>
           </p:cNvSpPr>
           <p:nvPr>
-            <p:ph type="dt" idx="1"/>
-          </p:nvPr>
-        </p:nvSpPr>
-        <p:spPr/>
-        <p:txBody>
-          <a:bodyPr/>
-          <a:p>
-            <a:r>
-              <a:rPr lang="en-HK"/>
+            <p:ph type="dt" idx="3"/>
+          </p:nvPr>
+        </p:nvSpPr>
+        <p:spPr/>
+        <p:txBody>
+          <a:bodyPr/>
+          <a:p>
+            <a:r>
+              <a:rPr lang="en-US"/>
               <a:t/>
             </a:r>
           </a:p>
@@ -318,8 +312,8 @@
         </p:nvSpPr>
         <p:spPr>
           <a:xfrm>
-            <a:off x="457200" y="274680"/>
-            <a:ext cx="8229240" cy="1142640"/>
+            <a:off x="457200" y="273600"/>
+            <a:ext cx="8229240" cy="1144800"/>
           </a:xfrm>
           <a:prstGeom prst="rect">
             <a:avLst/>
@@ -334,11 +328,11 @@
             <a:noAutofit/>
           </a:bodyPr>
           <a:p>
-            <a:endParaRPr b="0" lang="en-US" sz="1800" spc="-1" strike="noStrike">
-              <a:solidFill>
-                <a:srgbClr val="000000"/>
-              </a:solidFill>
-              <a:latin typeface="Calibri"/>
+            <a:pPr algn="ctr">
+              <a:buNone/>
+            </a:pPr>
+            <a:endParaRPr b="0" lang="en-US" sz="4400" spc="-1" strike="noStrike">
+              <a:latin typeface="Arial"/>
             </a:endParaRPr>
           </a:p>
         </p:txBody>
@@ -355,8 +349,8 @@
         </p:nvSpPr>
         <p:spPr>
           <a:xfrm>
-            <a:off x="457200" y="1600200"/>
-            <a:ext cx="4015800" cy="2158560"/>
+            <a:off x="457200" y="1604520"/>
+            <a:ext cx="4015800" cy="1896840"/>
           </a:xfrm>
           <a:prstGeom prst="rect">
             <a:avLst/>
@@ -372,10 +366,7 @@
           </a:bodyPr>
           <a:p>
             <a:endParaRPr b="0" lang="en-US" sz="3200" spc="-1" strike="noStrike">
-              <a:solidFill>
-                <a:srgbClr val="000000"/>
-              </a:solidFill>
-              <a:latin typeface="Calibri"/>
+              <a:latin typeface="Arial"/>
             </a:endParaRPr>
           </a:p>
         </p:txBody>
@@ -392,8 +383,8 @@
         </p:nvSpPr>
         <p:spPr>
           <a:xfrm>
-            <a:off x="4674240" y="1600200"/>
-            <a:ext cx="4015800" cy="2158560"/>
+            <a:off x="4674240" y="1604520"/>
+            <a:ext cx="4015800" cy="1896840"/>
           </a:xfrm>
           <a:prstGeom prst="rect">
             <a:avLst/>
@@ -409,10 +400,7 @@
           </a:bodyPr>
           <a:p>
             <a:endParaRPr b="0" lang="en-US" sz="3200" spc="-1" strike="noStrike">
-              <a:solidFill>
-                <a:srgbClr val="000000"/>
-              </a:solidFill>
-              <a:latin typeface="Calibri"/>
+              <a:latin typeface="Arial"/>
             </a:endParaRPr>
           </a:p>
         </p:txBody>
@@ -429,8 +417,8 @@
         </p:nvSpPr>
         <p:spPr>
           <a:xfrm>
-            <a:off x="457200" y="3964320"/>
-            <a:ext cx="4015800" cy="2158560"/>
+            <a:off x="457200" y="3682080"/>
+            <a:ext cx="4015800" cy="1896840"/>
           </a:xfrm>
           <a:prstGeom prst="rect">
             <a:avLst/>
@@ -446,10 +434,7 @@
           </a:bodyPr>
           <a:p>
             <a:endParaRPr b="0" lang="en-US" sz="3200" spc="-1" strike="noStrike">
-              <a:solidFill>
-                <a:srgbClr val="000000"/>
-              </a:solidFill>
-              <a:latin typeface="Calibri"/>
+              <a:latin typeface="Arial"/>
             </a:endParaRPr>
           </a:p>
         </p:txBody>
@@ -466,8 +451,8 @@
         </p:nvSpPr>
         <p:spPr>
           <a:xfrm>
-            <a:off x="4674240" y="3964320"/>
-            <a:ext cx="4015800" cy="2158560"/>
+            <a:off x="4674240" y="3682080"/>
+            <a:ext cx="4015800" cy="1896840"/>
           </a:xfrm>
           <a:prstGeom prst="rect">
             <a:avLst/>
@@ -483,10 +468,7 @@
           </a:bodyPr>
           <a:p>
             <a:endParaRPr b="0" lang="en-US" sz="3200" spc="-1" strike="noStrike">
-              <a:solidFill>
-                <a:srgbClr val="000000"/>
-              </a:solidFill>
-              <a:latin typeface="Calibri"/>
+              <a:latin typeface="Arial"/>
             </a:endParaRPr>
           </a:p>
         </p:txBody>
@@ -498,7 +480,7 @@
             <a:spLocks noGrp="1"/>
           </p:cNvSpPr>
           <p:nvPr>
-            <p:ph type="ftr" idx="2"/>
+            <p:ph type="ftr" idx="1"/>
           </p:nvPr>
         </p:nvSpPr>
         <p:spPr/>
@@ -518,14 +500,14 @@
             <a:spLocks noGrp="1"/>
           </p:cNvSpPr>
           <p:nvPr>
-            <p:ph type="sldNum" idx="3"/>
-          </p:nvPr>
-        </p:nvSpPr>
-        <p:spPr/>
-        <p:txBody>
-          <a:bodyPr/>
-          <a:p>
-            <a:fld id="{2443EA63-B063-482A-8213-4D26E797B169}" type="slidenum">
+            <p:ph type="sldNum" idx="2"/>
+          </p:nvPr>
+        </p:nvSpPr>
+        <p:spPr/>
+        <p:txBody>
+          <a:bodyPr/>
+          <a:p>
+            <a:fld id="{637B3073-4195-4688-9152-C54948969683}" type="slidenum">
               <a:t>&lt;#&gt;</a:t>
             </a:fld>
           </a:p>
@@ -538,15 +520,15 @@
             <a:spLocks noGrp="1"/>
           </p:cNvSpPr>
           <p:nvPr>
-            <p:ph type="dt" idx="1"/>
-          </p:nvPr>
-        </p:nvSpPr>
-        <p:spPr/>
-        <p:txBody>
-          <a:bodyPr/>
-          <a:p>
-            <a:r>
-              <a:rPr lang="en-HK"/>
+            <p:ph type="dt" idx="3"/>
+          </p:nvPr>
+        </p:nvSpPr>
+        <p:spPr/>
+        <p:txBody>
+          <a:bodyPr/>
+          <a:p>
+            <a:r>
+              <a:rPr lang="en-US"/>
               <a:t/>
             </a:r>
           </a:p>
@@ -586,8 +568,8 @@
         </p:nvSpPr>
         <p:spPr>
           <a:xfrm>
-            <a:off x="457200" y="274680"/>
-            <a:ext cx="8229240" cy="1142640"/>
+            <a:off x="457200" y="273600"/>
+            <a:ext cx="8229240" cy="1144800"/>
           </a:xfrm>
           <a:prstGeom prst="rect">
             <a:avLst/>
@@ -602,11 +584,11 @@
             <a:noAutofit/>
           </a:bodyPr>
           <a:p>
-            <a:endParaRPr b="0" lang="en-US" sz="1800" spc="-1" strike="noStrike">
-              <a:solidFill>
-                <a:srgbClr val="000000"/>
-              </a:solidFill>
-              <a:latin typeface="Calibri"/>
+            <a:pPr algn="ctr">
+              <a:buNone/>
+            </a:pPr>
+            <a:endParaRPr b="0" lang="en-US" sz="4400" spc="-1" strike="noStrike">
+              <a:latin typeface="Arial"/>
             </a:endParaRPr>
           </a:p>
         </p:txBody>
@@ -623,8 +605,8 @@
         </p:nvSpPr>
         <p:spPr>
           <a:xfrm>
-            <a:off x="457200" y="1600200"/>
-            <a:ext cx="2649600" cy="2158560"/>
+            <a:off x="457200" y="1604520"/>
+            <a:ext cx="2649600" cy="1896840"/>
           </a:xfrm>
           <a:prstGeom prst="rect">
             <a:avLst/>
@@ -640,10 +622,7 @@
           </a:bodyPr>
           <a:p>
             <a:endParaRPr b="0" lang="en-US" sz="3200" spc="-1" strike="noStrike">
-              <a:solidFill>
-                <a:srgbClr val="000000"/>
-              </a:solidFill>
-              <a:latin typeface="Calibri"/>
+              <a:latin typeface="Arial"/>
             </a:endParaRPr>
           </a:p>
         </p:txBody>
@@ -660,8 +639,8 @@
         </p:nvSpPr>
         <p:spPr>
           <a:xfrm>
-            <a:off x="3239640" y="1600200"/>
-            <a:ext cx="2649600" cy="2158560"/>
+            <a:off x="3239640" y="1604520"/>
+            <a:ext cx="2649600" cy="1896840"/>
           </a:xfrm>
           <a:prstGeom prst="rect">
             <a:avLst/>
@@ -677,10 +656,7 @@
           </a:bodyPr>
           <a:p>
             <a:endParaRPr b="0" lang="en-US" sz="3200" spc="-1" strike="noStrike">
-              <a:solidFill>
-                <a:srgbClr val="000000"/>
-              </a:solidFill>
-              <a:latin typeface="Calibri"/>
+              <a:latin typeface="Arial"/>
             </a:endParaRPr>
           </a:p>
         </p:txBody>
@@ -697,8 +673,8 @@
         </p:nvSpPr>
         <p:spPr>
           <a:xfrm>
-            <a:off x="6022080" y="1600200"/>
-            <a:ext cx="2649600" cy="2158560"/>
+            <a:off x="6022080" y="1604520"/>
+            <a:ext cx="2649600" cy="1896840"/>
           </a:xfrm>
           <a:prstGeom prst="rect">
             <a:avLst/>
@@ -714,10 +690,7 @@
           </a:bodyPr>
           <a:p>
             <a:endParaRPr b="0" lang="en-US" sz="3200" spc="-1" strike="noStrike">
-              <a:solidFill>
-                <a:srgbClr val="000000"/>
-              </a:solidFill>
-              <a:latin typeface="Calibri"/>
+              <a:latin typeface="Arial"/>
             </a:endParaRPr>
           </a:p>
         </p:txBody>
@@ -734,8 +707,8 @@
         </p:nvSpPr>
         <p:spPr>
           <a:xfrm>
-            <a:off x="457200" y="3964320"/>
-            <a:ext cx="2649600" cy="2158560"/>
+            <a:off x="457200" y="3682080"/>
+            <a:ext cx="2649600" cy="1896840"/>
           </a:xfrm>
           <a:prstGeom prst="rect">
             <a:avLst/>
@@ -751,10 +724,7 @@
           </a:bodyPr>
           <a:p>
             <a:endParaRPr b="0" lang="en-US" sz="3200" spc="-1" strike="noStrike">
-              <a:solidFill>
-                <a:srgbClr val="000000"/>
-              </a:solidFill>
-              <a:latin typeface="Calibri"/>
+              <a:latin typeface="Arial"/>
             </a:endParaRPr>
           </a:p>
         </p:txBody>
@@ -771,8 +741,8 @@
         </p:nvSpPr>
         <p:spPr>
           <a:xfrm>
-            <a:off x="3239640" y="3964320"/>
-            <a:ext cx="2649600" cy="2158560"/>
+            <a:off x="3239640" y="3682080"/>
+            <a:ext cx="2649600" cy="1896840"/>
           </a:xfrm>
           <a:prstGeom prst="rect">
             <a:avLst/>
@@ -788,10 +758,7 @@
           </a:bodyPr>
           <a:p>
             <a:endParaRPr b="0" lang="en-US" sz="3200" spc="-1" strike="noStrike">
-              <a:solidFill>
-                <a:srgbClr val="000000"/>
-              </a:solidFill>
-              <a:latin typeface="Calibri"/>
+              <a:latin typeface="Arial"/>
             </a:endParaRPr>
           </a:p>
         </p:txBody>
@@ -808,8 +775,8 @@
         </p:nvSpPr>
         <p:spPr>
           <a:xfrm>
-            <a:off x="6022080" y="3964320"/>
-            <a:ext cx="2649600" cy="2158560"/>
+            <a:off x="6022080" y="3682080"/>
+            <a:ext cx="2649600" cy="1896840"/>
           </a:xfrm>
           <a:prstGeom prst="rect">
             <a:avLst/>
@@ -825,10 +792,7 @@
           </a:bodyPr>
           <a:p>
             <a:endParaRPr b="0" lang="en-US" sz="3200" spc="-1" strike="noStrike">
-              <a:solidFill>
-                <a:srgbClr val="000000"/>
-              </a:solidFill>
-              <a:latin typeface="Calibri"/>
+              <a:latin typeface="Arial"/>
             </a:endParaRPr>
           </a:p>
         </p:txBody>
@@ -840,7 +804,7 @@
             <a:spLocks noGrp="1"/>
           </p:cNvSpPr>
           <p:nvPr>
-            <p:ph type="ftr" idx="2"/>
+            <p:ph type="ftr" idx="1"/>
           </p:nvPr>
         </p:nvSpPr>
         <p:spPr/>
@@ -860,14 +824,14 @@
             <a:spLocks noGrp="1"/>
           </p:cNvSpPr>
           <p:nvPr>
-            <p:ph type="sldNum" idx="3"/>
-          </p:nvPr>
-        </p:nvSpPr>
-        <p:spPr/>
-        <p:txBody>
-          <a:bodyPr/>
-          <a:p>
-            <a:fld id="{347E54D7-0B57-4F05-8FF7-B350E4ED6F82}" type="slidenum">
+            <p:ph type="sldNum" idx="2"/>
+          </p:nvPr>
+        </p:nvSpPr>
+        <p:spPr/>
+        <p:txBody>
+          <a:bodyPr/>
+          <a:p>
+            <a:fld id="{3F37AF51-61D6-44B8-96CE-F2C11350F31E}" type="slidenum">
               <a:t>&lt;#&gt;</a:t>
             </a:fld>
           </a:p>
@@ -880,15 +844,15 @@
             <a:spLocks noGrp="1"/>
           </p:cNvSpPr>
           <p:nvPr>
-            <p:ph type="dt" idx="1"/>
-          </p:nvPr>
-        </p:nvSpPr>
-        <p:spPr/>
-        <p:txBody>
-          <a:bodyPr/>
-          <a:p>
-            <a:r>
-              <a:rPr lang="en-HK"/>
+            <p:ph type="dt" idx="3"/>
+          </p:nvPr>
+        </p:nvSpPr>
+        <p:spPr/>
+        <p:txBody>
+          <a:bodyPr/>
+          <a:p>
+            <a:r>
+              <a:rPr lang="en-US"/>
               <a:t/>
             </a:r>
           </a:p>
@@ -928,45 +892,8 @@
         </p:nvSpPr>
         <p:spPr>
           <a:xfrm>
-            <a:off x="457200" y="274680"/>
-            <a:ext cx="8229240" cy="1142640"/>
-          </a:xfrm>
-          <a:prstGeom prst="rect">
-            <a:avLst/>
-          </a:prstGeom>
-          <a:noFill/>
-          <a:ln w="0">
-            <a:noFill/>
-          </a:ln>
-        </p:spPr>
-        <p:txBody>
-          <a:bodyPr lIns="0" rIns="0" tIns="0" bIns="0" anchor="ctr">
-            <a:noAutofit/>
-          </a:bodyPr>
-          <a:p>
-            <a:endParaRPr b="0" lang="en-US" sz="1800" spc="-1" strike="noStrike">
-              <a:solidFill>
-                <a:srgbClr val="000000"/>
-              </a:solidFill>
-              <a:latin typeface="Calibri"/>
-            </a:endParaRPr>
-          </a:p>
-        </p:txBody>
-      </p:sp>
-      <p:sp>
-        <p:nvSpPr>
-          <p:cNvPr id="6" name="PlaceHolder 2"/>
-          <p:cNvSpPr>
-            <a:spLocks noGrp="1"/>
-          </p:cNvSpPr>
-          <p:nvPr>
-            <p:ph type="subTitle"/>
-          </p:nvPr>
-        </p:nvSpPr>
-        <p:spPr>
-          <a:xfrm>
-            <a:off x="457200" y="1600200"/>
-            <a:ext cx="8229240" cy="4525560"/>
+            <a:off x="457200" y="273600"/>
+            <a:ext cx="8229240" cy="1144800"/>
           </a:xfrm>
           <a:prstGeom prst="rect">
             <a:avLst/>
@@ -984,7 +911,44 @@
             <a:pPr algn="ctr">
               <a:buNone/>
             </a:pPr>
-            <a:endParaRPr b="0" lang="en-HK" sz="3200" spc="-1" strike="noStrike">
+            <a:endParaRPr b="0" lang="en-US" sz="4400" spc="-1" strike="noStrike">
+              <a:latin typeface="Arial"/>
+            </a:endParaRPr>
+          </a:p>
+        </p:txBody>
+      </p:sp>
+      <p:sp>
+        <p:nvSpPr>
+          <p:cNvPr id="6" name="PlaceHolder 2"/>
+          <p:cNvSpPr>
+            <a:spLocks noGrp="1"/>
+          </p:cNvSpPr>
+          <p:nvPr>
+            <p:ph type="subTitle"/>
+          </p:nvPr>
+        </p:nvSpPr>
+        <p:spPr>
+          <a:xfrm>
+            <a:off x="457200" y="1604520"/>
+            <a:ext cx="8229240" cy="3977280"/>
+          </a:xfrm>
+          <a:prstGeom prst="rect">
+            <a:avLst/>
+          </a:prstGeom>
+          <a:noFill/>
+          <a:ln w="0">
+            <a:noFill/>
+          </a:ln>
+        </p:spPr>
+        <p:txBody>
+          <a:bodyPr lIns="0" rIns="0" tIns="0" bIns="0" anchor="ctr">
+            <a:noAutofit/>
+          </a:bodyPr>
+          <a:p>
+            <a:pPr algn="ctr">
+              <a:buNone/>
+            </a:pPr>
+            <a:endParaRPr b="0" lang="en-US" sz="3200" spc="-1" strike="noStrike">
               <a:latin typeface="Arial"/>
             </a:endParaRPr>
           </a:p>
@@ -997,7 +961,7 @@
             <a:spLocks noGrp="1"/>
           </p:cNvSpPr>
           <p:nvPr>
-            <p:ph type="ftr" idx="2"/>
+            <p:ph type="ftr" idx="1"/>
           </p:nvPr>
         </p:nvSpPr>
         <p:spPr/>
@@ -1017,14 +981,14 @@
             <a:spLocks noGrp="1"/>
           </p:cNvSpPr>
           <p:nvPr>
-            <p:ph type="sldNum" idx="3"/>
-          </p:nvPr>
-        </p:nvSpPr>
-        <p:spPr/>
-        <p:txBody>
-          <a:bodyPr/>
-          <a:p>
-            <a:fld id="{C2B22A33-8945-47C4-825B-9894EC6D4A44}" type="slidenum">
+            <p:ph type="sldNum" idx="2"/>
+          </p:nvPr>
+        </p:nvSpPr>
+        <p:spPr/>
+        <p:txBody>
+          <a:bodyPr/>
+          <a:p>
+            <a:fld id="{4028048C-4092-4295-B68A-4F26198D8D86}" type="slidenum">
               <a:t>&lt;#&gt;</a:t>
             </a:fld>
           </a:p>
@@ -1037,15 +1001,15 @@
             <a:spLocks noGrp="1"/>
           </p:cNvSpPr>
           <p:nvPr>
-            <p:ph type="dt" idx="1"/>
-          </p:nvPr>
-        </p:nvSpPr>
-        <p:spPr/>
-        <p:txBody>
-          <a:bodyPr/>
-          <a:p>
-            <a:r>
-              <a:rPr lang="en-HK"/>
+            <p:ph type="dt" idx="3"/>
+          </p:nvPr>
+        </p:nvSpPr>
+        <p:spPr/>
+        <p:txBody>
+          <a:bodyPr/>
+          <a:p>
+            <a:r>
+              <a:rPr lang="en-US"/>
               <a:t/>
             </a:r>
           </a:p>
@@ -1085,8 +1049,8 @@
         </p:nvSpPr>
         <p:spPr>
           <a:xfrm>
-            <a:off x="457200" y="274680"/>
-            <a:ext cx="8229240" cy="1142640"/>
+            <a:off x="457200" y="273600"/>
+            <a:ext cx="8229240" cy="1144800"/>
           </a:xfrm>
           <a:prstGeom prst="rect">
             <a:avLst/>
@@ -1101,11 +1065,11 @@
             <a:noAutofit/>
           </a:bodyPr>
           <a:p>
-            <a:endParaRPr b="0" lang="en-US" sz="1800" spc="-1" strike="noStrike">
-              <a:solidFill>
-                <a:srgbClr val="000000"/>
-              </a:solidFill>
-              <a:latin typeface="Calibri"/>
+            <a:pPr algn="ctr">
+              <a:buNone/>
+            </a:pPr>
+            <a:endParaRPr b="0" lang="en-US" sz="4400" spc="-1" strike="noStrike">
+              <a:latin typeface="Arial"/>
             </a:endParaRPr>
           </a:p>
         </p:txBody>
@@ -1122,8 +1086,8 @@
         </p:nvSpPr>
         <p:spPr>
           <a:xfrm>
-            <a:off x="457200" y="1600200"/>
-            <a:ext cx="8229240" cy="4525560"/>
+            <a:off x="457200" y="1604520"/>
+            <a:ext cx="8229240" cy="3977280"/>
           </a:xfrm>
           <a:prstGeom prst="rect">
             <a:avLst/>
@@ -1139,10 +1103,7 @@
           </a:bodyPr>
           <a:p>
             <a:endParaRPr b="0" lang="en-US" sz="3200" spc="-1" strike="noStrike">
-              <a:solidFill>
-                <a:srgbClr val="000000"/>
-              </a:solidFill>
-              <a:latin typeface="Calibri"/>
+              <a:latin typeface="Arial"/>
             </a:endParaRPr>
           </a:p>
         </p:txBody>
@@ -1154,7 +1115,7 @@
             <a:spLocks noGrp="1"/>
           </p:cNvSpPr>
           <p:nvPr>
-            <p:ph type="ftr" idx="2"/>
+            <p:ph type="ftr" idx="1"/>
           </p:nvPr>
         </p:nvSpPr>
         <p:spPr/>
@@ -1174,14 +1135,14 @@
             <a:spLocks noGrp="1"/>
           </p:cNvSpPr>
           <p:nvPr>
-            <p:ph type="sldNum" idx="3"/>
-          </p:nvPr>
-        </p:nvSpPr>
-        <p:spPr/>
-        <p:txBody>
-          <a:bodyPr/>
-          <a:p>
-            <a:fld id="{C3EE5AEA-9A0E-4A3B-93C8-92A7BCC02E0B}" type="slidenum">
+            <p:ph type="sldNum" idx="2"/>
+          </p:nvPr>
+        </p:nvSpPr>
+        <p:spPr/>
+        <p:txBody>
+          <a:bodyPr/>
+          <a:p>
+            <a:fld id="{1057B449-30FE-4BC9-AA3E-67DC65C20720}" type="slidenum">
               <a:t>&lt;#&gt;</a:t>
             </a:fld>
           </a:p>
@@ -1194,15 +1155,15 @@
             <a:spLocks noGrp="1"/>
           </p:cNvSpPr>
           <p:nvPr>
-            <p:ph type="dt" idx="1"/>
-          </p:nvPr>
-        </p:nvSpPr>
-        <p:spPr/>
-        <p:txBody>
-          <a:bodyPr/>
-          <a:p>
-            <a:r>
-              <a:rPr lang="en-HK"/>
+            <p:ph type="dt" idx="3"/>
+          </p:nvPr>
+        </p:nvSpPr>
+        <p:spPr/>
+        <p:txBody>
+          <a:bodyPr/>
+          <a:p>
+            <a:r>
+              <a:rPr lang="en-US"/>
               <a:t/>
             </a:r>
           </a:p>
@@ -1242,8 +1203,8 @@
         </p:nvSpPr>
         <p:spPr>
           <a:xfrm>
-            <a:off x="457200" y="274680"/>
-            <a:ext cx="8229240" cy="1142640"/>
+            <a:off x="457200" y="273600"/>
+            <a:ext cx="8229240" cy="1144800"/>
           </a:xfrm>
           <a:prstGeom prst="rect">
             <a:avLst/>
@@ -1258,11 +1219,11 @@
             <a:noAutofit/>
           </a:bodyPr>
           <a:p>
-            <a:endParaRPr b="0" lang="en-US" sz="1800" spc="-1" strike="noStrike">
-              <a:solidFill>
-                <a:srgbClr val="000000"/>
-              </a:solidFill>
-              <a:latin typeface="Calibri"/>
+            <a:pPr algn="ctr">
+              <a:buNone/>
+            </a:pPr>
+            <a:endParaRPr b="0" lang="en-US" sz="4400" spc="-1" strike="noStrike">
+              <a:latin typeface="Arial"/>
             </a:endParaRPr>
           </a:p>
         </p:txBody>
@@ -1279,8 +1240,8 @@
         </p:nvSpPr>
         <p:spPr>
           <a:xfrm>
-            <a:off x="457200" y="1600200"/>
-            <a:ext cx="4015800" cy="4525560"/>
+            <a:off x="457200" y="1604520"/>
+            <a:ext cx="4015800" cy="3977280"/>
           </a:xfrm>
           <a:prstGeom prst="rect">
             <a:avLst/>
@@ -1296,10 +1257,7 @@
           </a:bodyPr>
           <a:p>
             <a:endParaRPr b="0" lang="en-US" sz="3200" spc="-1" strike="noStrike">
-              <a:solidFill>
-                <a:srgbClr val="000000"/>
-              </a:solidFill>
-              <a:latin typeface="Calibri"/>
+              <a:latin typeface="Arial"/>
             </a:endParaRPr>
           </a:p>
         </p:txBody>
@@ -1316,8 +1274,8 @@
         </p:nvSpPr>
         <p:spPr>
           <a:xfrm>
-            <a:off x="4674240" y="1600200"/>
-            <a:ext cx="4015800" cy="4525560"/>
+            <a:off x="4674240" y="1604520"/>
+            <a:ext cx="4015800" cy="3977280"/>
           </a:xfrm>
           <a:prstGeom prst="rect">
             <a:avLst/>
@@ -1333,10 +1291,7 @@
           </a:bodyPr>
           <a:p>
             <a:endParaRPr b="0" lang="en-US" sz="3200" spc="-1" strike="noStrike">
-              <a:solidFill>
-                <a:srgbClr val="000000"/>
-              </a:solidFill>
-              <a:latin typeface="Calibri"/>
+              <a:latin typeface="Arial"/>
             </a:endParaRPr>
           </a:p>
         </p:txBody>
@@ -1348,7 +1303,7 @@
             <a:spLocks noGrp="1"/>
           </p:cNvSpPr>
           <p:nvPr>
-            <p:ph type="ftr" idx="2"/>
+            <p:ph type="ftr" idx="1"/>
           </p:nvPr>
         </p:nvSpPr>
         <p:spPr/>
@@ -1368,14 +1323,14 @@
             <a:spLocks noGrp="1"/>
           </p:cNvSpPr>
           <p:nvPr>
-            <p:ph type="sldNum" idx="3"/>
-          </p:nvPr>
-        </p:nvSpPr>
-        <p:spPr/>
-        <p:txBody>
-          <a:bodyPr/>
-          <a:p>
-            <a:fld id="{6E8ABD42-D524-451E-9666-A617626C2418}" type="slidenum">
+            <p:ph type="sldNum" idx="2"/>
+          </p:nvPr>
+        </p:nvSpPr>
+        <p:spPr/>
+        <p:txBody>
+          <a:bodyPr/>
+          <a:p>
+            <a:fld id="{9B4CEEF7-5FBF-47BE-91D0-683162593856}" type="slidenum">
               <a:t>&lt;#&gt;</a:t>
             </a:fld>
           </a:p>
@@ -1388,15 +1343,15 @@
             <a:spLocks noGrp="1"/>
           </p:cNvSpPr>
           <p:nvPr>
-            <p:ph type="dt" idx="1"/>
-          </p:nvPr>
-        </p:nvSpPr>
-        <p:spPr/>
-        <p:txBody>
-          <a:bodyPr/>
-          <a:p>
-            <a:r>
-              <a:rPr lang="en-HK"/>
+            <p:ph type="dt" idx="3"/>
+          </p:nvPr>
+        </p:nvSpPr>
+        <p:spPr/>
+        <p:txBody>
+          <a:bodyPr/>
+          <a:p>
+            <a:r>
+              <a:rPr lang="en-US"/>
               <a:t/>
             </a:r>
           </a:p>
@@ -1436,8 +1391,8 @@
         </p:nvSpPr>
         <p:spPr>
           <a:xfrm>
-            <a:off x="457200" y="274680"/>
-            <a:ext cx="8229240" cy="1142640"/>
+            <a:off x="457200" y="273600"/>
+            <a:ext cx="8229240" cy="1144800"/>
           </a:xfrm>
           <a:prstGeom prst="rect">
             <a:avLst/>
@@ -1452,11 +1407,11 @@
             <a:noAutofit/>
           </a:bodyPr>
           <a:p>
-            <a:endParaRPr b="0" lang="en-US" sz="1800" spc="-1" strike="noStrike">
-              <a:solidFill>
-                <a:srgbClr val="000000"/>
-              </a:solidFill>
-              <a:latin typeface="Calibri"/>
+            <a:pPr algn="ctr">
+              <a:buNone/>
+            </a:pPr>
+            <a:endParaRPr b="0" lang="en-US" sz="4400" spc="-1" strike="noStrike">
+              <a:latin typeface="Arial"/>
             </a:endParaRPr>
           </a:p>
         </p:txBody>
@@ -1468,7 +1423,7 @@
             <a:spLocks noGrp="1"/>
           </p:cNvSpPr>
           <p:nvPr>
-            <p:ph type="ftr" idx="2"/>
+            <p:ph type="ftr" idx="1"/>
           </p:nvPr>
         </p:nvSpPr>
         <p:spPr/>
@@ -1488,14 +1443,14 @@
             <a:spLocks noGrp="1"/>
           </p:cNvSpPr>
           <p:nvPr>
-            <p:ph type="sldNum" idx="3"/>
-          </p:nvPr>
-        </p:nvSpPr>
-        <p:spPr/>
-        <p:txBody>
-          <a:bodyPr/>
-          <a:p>
-            <a:fld id="{7797B15A-6008-448F-A2CC-B1663F93733F}" type="slidenum">
+            <p:ph type="sldNum" idx="2"/>
+          </p:nvPr>
+        </p:nvSpPr>
+        <p:spPr/>
+        <p:txBody>
+          <a:bodyPr/>
+          <a:p>
+            <a:fld id="{8B551D21-248E-4ED6-B922-02126A6963D2}" type="slidenum">
               <a:t>&lt;#&gt;</a:t>
             </a:fld>
           </a:p>
@@ -1508,15 +1463,15 @@
             <a:spLocks noGrp="1"/>
           </p:cNvSpPr>
           <p:nvPr>
-            <p:ph type="dt" idx="1"/>
-          </p:nvPr>
-        </p:nvSpPr>
-        <p:spPr/>
-        <p:txBody>
-          <a:bodyPr/>
-          <a:p>
-            <a:r>
-              <a:rPr lang="en-HK"/>
+            <p:ph type="dt" idx="3"/>
+          </p:nvPr>
+        </p:nvSpPr>
+        <p:spPr/>
+        <p:txBody>
+          <a:bodyPr/>
+          <a:p>
+            <a:r>
+              <a:rPr lang="en-US"/>
               <a:t/>
             </a:r>
           </a:p>
@@ -1556,8 +1511,8 @@
         </p:nvSpPr>
         <p:spPr>
           <a:xfrm>
-            <a:off x="457200" y="274680"/>
-            <a:ext cx="8229240" cy="5297760"/>
+            <a:off x="457200" y="273600"/>
+            <a:ext cx="8229240" cy="5307840"/>
           </a:xfrm>
           <a:prstGeom prst="rect">
             <a:avLst/>
@@ -1575,7 +1530,7 @@
             <a:pPr algn="ctr">
               <a:buNone/>
             </a:pPr>
-            <a:endParaRPr b="0" lang="en-HK" sz="3200" spc="-1" strike="noStrike">
+            <a:endParaRPr b="0" lang="en-US" sz="3200" spc="-1" strike="noStrike">
               <a:latin typeface="Arial"/>
             </a:endParaRPr>
           </a:p>
@@ -1588,7 +1543,7 @@
             <a:spLocks noGrp="1"/>
           </p:cNvSpPr>
           <p:nvPr>
-            <p:ph type="ftr" idx="2"/>
+            <p:ph type="ftr" idx="1"/>
           </p:nvPr>
         </p:nvSpPr>
         <p:spPr/>
@@ -1608,14 +1563,14 @@
             <a:spLocks noGrp="1"/>
           </p:cNvSpPr>
           <p:nvPr>
-            <p:ph type="sldNum" idx="3"/>
-          </p:nvPr>
-        </p:nvSpPr>
-        <p:spPr/>
-        <p:txBody>
-          <a:bodyPr/>
-          <a:p>
-            <a:fld id="{5759A802-C792-4F63-BD57-ABA388256DEF}" type="slidenum">
+            <p:ph type="sldNum" idx="2"/>
+          </p:nvPr>
+        </p:nvSpPr>
+        <p:spPr/>
+        <p:txBody>
+          <a:bodyPr/>
+          <a:p>
+            <a:fld id="{9C79686C-3F3F-4280-92B0-301B7F7903BB}" type="slidenum">
               <a:t>&lt;#&gt;</a:t>
             </a:fld>
           </a:p>
@@ -1628,15 +1583,15 @@
             <a:spLocks noGrp="1"/>
           </p:cNvSpPr>
           <p:nvPr>
-            <p:ph type="dt" idx="1"/>
-          </p:nvPr>
-        </p:nvSpPr>
-        <p:spPr/>
-        <p:txBody>
-          <a:bodyPr/>
-          <a:p>
-            <a:r>
-              <a:rPr lang="en-HK"/>
+            <p:ph type="dt" idx="3"/>
+          </p:nvPr>
+        </p:nvSpPr>
+        <p:spPr/>
+        <p:txBody>
+          <a:bodyPr/>
+          <a:p>
+            <a:r>
+              <a:rPr lang="en-US"/>
               <a:t/>
             </a:r>
           </a:p>
@@ -1676,8 +1631,8 @@
         </p:nvSpPr>
         <p:spPr>
           <a:xfrm>
-            <a:off x="457200" y="274680"/>
-            <a:ext cx="8229240" cy="1142640"/>
+            <a:off x="457200" y="273600"/>
+            <a:ext cx="8229240" cy="1144800"/>
           </a:xfrm>
           <a:prstGeom prst="rect">
             <a:avLst/>
@@ -1692,11 +1647,11 @@
             <a:noAutofit/>
           </a:bodyPr>
           <a:p>
-            <a:endParaRPr b="0" lang="en-US" sz="1800" spc="-1" strike="noStrike">
-              <a:solidFill>
-                <a:srgbClr val="000000"/>
-              </a:solidFill>
-              <a:latin typeface="Calibri"/>
+            <a:pPr algn="ctr">
+              <a:buNone/>
+            </a:pPr>
+            <a:endParaRPr b="0" lang="en-US" sz="4400" spc="-1" strike="noStrike">
+              <a:latin typeface="Arial"/>
             </a:endParaRPr>
           </a:p>
         </p:txBody>
@@ -1713,8 +1668,8 @@
         </p:nvSpPr>
         <p:spPr>
           <a:xfrm>
-            <a:off x="457200" y="1600200"/>
-            <a:ext cx="4015800" cy="2158560"/>
+            <a:off x="457200" y="1604520"/>
+            <a:ext cx="4015800" cy="1896840"/>
           </a:xfrm>
           <a:prstGeom prst="rect">
             <a:avLst/>
@@ -1730,10 +1685,7 @@
           </a:bodyPr>
           <a:p>
             <a:endParaRPr b="0" lang="en-US" sz="3200" spc="-1" strike="noStrike">
-              <a:solidFill>
-                <a:srgbClr val="000000"/>
-              </a:solidFill>
-              <a:latin typeface="Calibri"/>
+              <a:latin typeface="Arial"/>
             </a:endParaRPr>
           </a:p>
         </p:txBody>
@@ -1750,8 +1702,8 @@
         </p:nvSpPr>
         <p:spPr>
           <a:xfrm>
-            <a:off x="4674240" y="1600200"/>
-            <a:ext cx="4015800" cy="4525560"/>
+            <a:off x="4674240" y="1604520"/>
+            <a:ext cx="4015800" cy="3977280"/>
           </a:xfrm>
           <a:prstGeom prst="rect">
             <a:avLst/>
@@ -1767,10 +1719,7 @@
           </a:bodyPr>
           <a:p>
             <a:endParaRPr b="0" lang="en-US" sz="3200" spc="-1" strike="noStrike">
-              <a:solidFill>
-                <a:srgbClr val="000000"/>
-              </a:solidFill>
-              <a:latin typeface="Calibri"/>
+              <a:latin typeface="Arial"/>
             </a:endParaRPr>
           </a:p>
         </p:txBody>
@@ -1787,8 +1736,8 @@
         </p:nvSpPr>
         <p:spPr>
           <a:xfrm>
-            <a:off x="457200" y="3964320"/>
-            <a:ext cx="4015800" cy="2158560"/>
+            <a:off x="457200" y="3682080"/>
+            <a:ext cx="4015800" cy="1896840"/>
           </a:xfrm>
           <a:prstGeom prst="rect">
             <a:avLst/>
@@ -1804,10 +1753,7 @@
           </a:bodyPr>
           <a:p>
             <a:endParaRPr b="0" lang="en-US" sz="3200" spc="-1" strike="noStrike">
-              <a:solidFill>
-                <a:srgbClr val="000000"/>
-              </a:solidFill>
-              <a:latin typeface="Calibri"/>
+              <a:latin typeface="Arial"/>
             </a:endParaRPr>
           </a:p>
         </p:txBody>
@@ -1819,7 +1765,7 @@
             <a:spLocks noGrp="1"/>
           </p:cNvSpPr>
           <p:nvPr>
-            <p:ph type="ftr" idx="2"/>
+            <p:ph type="ftr" idx="1"/>
           </p:nvPr>
         </p:nvSpPr>
         <p:spPr/>
@@ -1839,14 +1785,14 @@
             <a:spLocks noGrp="1"/>
           </p:cNvSpPr>
           <p:nvPr>
-            <p:ph type="sldNum" idx="3"/>
-          </p:nvPr>
-        </p:nvSpPr>
-        <p:spPr/>
-        <p:txBody>
-          <a:bodyPr/>
-          <a:p>
-            <a:fld id="{BCE47AD9-BEDF-4620-B53F-ED88867D3E85}" type="slidenum">
+            <p:ph type="sldNum" idx="2"/>
+          </p:nvPr>
+        </p:nvSpPr>
+        <p:spPr/>
+        <p:txBody>
+          <a:bodyPr/>
+          <a:p>
+            <a:fld id="{891B236E-6B1B-4195-8B13-0EF31CDDA83B}" type="slidenum">
               <a:t>&lt;#&gt;</a:t>
             </a:fld>
           </a:p>
@@ -1859,15 +1805,15 @@
             <a:spLocks noGrp="1"/>
           </p:cNvSpPr>
           <p:nvPr>
-            <p:ph type="dt" idx="1"/>
-          </p:nvPr>
-        </p:nvSpPr>
-        <p:spPr/>
-        <p:txBody>
-          <a:bodyPr/>
-          <a:p>
-            <a:r>
-              <a:rPr lang="en-HK"/>
+            <p:ph type="dt" idx="3"/>
+          </p:nvPr>
+        </p:nvSpPr>
+        <p:spPr/>
+        <p:txBody>
+          <a:bodyPr/>
+          <a:p>
+            <a:r>
+              <a:rPr lang="en-US"/>
               <a:t/>
             </a:r>
           </a:p>
@@ -1907,8 +1853,8 @@
         </p:nvSpPr>
         <p:spPr>
           <a:xfrm>
-            <a:off x="457200" y="274680"/>
-            <a:ext cx="8229240" cy="1142640"/>
+            <a:off x="457200" y="273600"/>
+            <a:ext cx="8229240" cy="1144800"/>
           </a:xfrm>
           <a:prstGeom prst="rect">
             <a:avLst/>
@@ -1923,11 +1869,11 @@
             <a:noAutofit/>
           </a:bodyPr>
           <a:p>
-            <a:endParaRPr b="0" lang="en-US" sz="1800" spc="-1" strike="noStrike">
-              <a:solidFill>
-                <a:srgbClr val="000000"/>
-              </a:solidFill>
-              <a:latin typeface="Calibri"/>
+            <a:pPr algn="ctr">
+              <a:buNone/>
+            </a:pPr>
+            <a:endParaRPr b="0" lang="en-US" sz="4400" spc="-1" strike="noStrike">
+              <a:latin typeface="Arial"/>
             </a:endParaRPr>
           </a:p>
         </p:txBody>
@@ -1944,8 +1890,8 @@
         </p:nvSpPr>
         <p:spPr>
           <a:xfrm>
-            <a:off x="457200" y="1600200"/>
-            <a:ext cx="4015800" cy="4525560"/>
+            <a:off x="457200" y="1604520"/>
+            <a:ext cx="4015800" cy="3977280"/>
           </a:xfrm>
           <a:prstGeom prst="rect">
             <a:avLst/>
@@ -1961,10 +1907,7 @@
           </a:bodyPr>
           <a:p>
             <a:endParaRPr b="0" lang="en-US" sz="3200" spc="-1" strike="noStrike">
-              <a:solidFill>
-                <a:srgbClr val="000000"/>
-              </a:solidFill>
-              <a:latin typeface="Calibri"/>
+              <a:latin typeface="Arial"/>
             </a:endParaRPr>
           </a:p>
         </p:txBody>
@@ -1981,8 +1924,8 @@
         </p:nvSpPr>
         <p:spPr>
           <a:xfrm>
-            <a:off x="4674240" y="1600200"/>
-            <a:ext cx="4015800" cy="2158560"/>
+            <a:off x="4674240" y="1604520"/>
+            <a:ext cx="4015800" cy="1896840"/>
           </a:xfrm>
           <a:prstGeom prst="rect">
             <a:avLst/>
@@ -1998,10 +1941,7 @@
           </a:bodyPr>
           <a:p>
             <a:endParaRPr b="0" lang="en-US" sz="3200" spc="-1" strike="noStrike">
-              <a:solidFill>
-                <a:srgbClr val="000000"/>
-              </a:solidFill>
-              <a:latin typeface="Calibri"/>
+              <a:latin typeface="Arial"/>
             </a:endParaRPr>
           </a:p>
         </p:txBody>
@@ -2018,8 +1958,8 @@
         </p:nvSpPr>
         <p:spPr>
           <a:xfrm>
-            <a:off x="4674240" y="3964320"/>
-            <a:ext cx="4015800" cy="2158560"/>
+            <a:off x="4674240" y="3682080"/>
+            <a:ext cx="4015800" cy="1896840"/>
           </a:xfrm>
           <a:prstGeom prst="rect">
             <a:avLst/>
@@ -2035,10 +1975,7 @@
           </a:bodyPr>
           <a:p>
             <a:endParaRPr b="0" lang="en-US" sz="3200" spc="-1" strike="noStrike">
-              <a:solidFill>
-                <a:srgbClr val="000000"/>
-              </a:solidFill>
-              <a:latin typeface="Calibri"/>
+              <a:latin typeface="Arial"/>
             </a:endParaRPr>
           </a:p>
         </p:txBody>
@@ -2050,7 +1987,7 @@
             <a:spLocks noGrp="1"/>
           </p:cNvSpPr>
           <p:nvPr>
-            <p:ph type="ftr" idx="2"/>
+            <p:ph type="ftr" idx="1"/>
           </p:nvPr>
         </p:nvSpPr>
         <p:spPr/>
@@ -2070,14 +2007,14 @@
             <a:spLocks noGrp="1"/>
           </p:cNvSpPr>
           <p:nvPr>
-            <p:ph type="sldNum" idx="3"/>
-          </p:nvPr>
-        </p:nvSpPr>
-        <p:spPr/>
-        <p:txBody>
-          <a:bodyPr/>
-          <a:p>
-            <a:fld id="{F29D145C-E525-4AE1-913F-B8DE667B9A43}" type="slidenum">
+            <p:ph type="sldNum" idx="2"/>
+          </p:nvPr>
+        </p:nvSpPr>
+        <p:spPr/>
+        <p:txBody>
+          <a:bodyPr/>
+          <a:p>
+            <a:fld id="{F102A93B-0026-4961-9C48-5468DB30AEEB}" type="slidenum">
               <a:t>&lt;#&gt;</a:t>
             </a:fld>
           </a:p>
@@ -2090,15 +2027,15 @@
             <a:spLocks noGrp="1"/>
           </p:cNvSpPr>
           <p:nvPr>
-            <p:ph type="dt" idx="1"/>
-          </p:nvPr>
-        </p:nvSpPr>
-        <p:spPr/>
-        <p:txBody>
-          <a:bodyPr/>
-          <a:p>
-            <a:r>
-              <a:rPr lang="en-HK"/>
+            <p:ph type="dt" idx="3"/>
+          </p:nvPr>
+        </p:nvSpPr>
+        <p:spPr/>
+        <p:txBody>
+          <a:bodyPr/>
+          <a:p>
+            <a:r>
+              <a:rPr lang="en-US"/>
               <a:t/>
             </a:r>
           </a:p>
@@ -2138,8 +2075,8 @@
         </p:nvSpPr>
         <p:spPr>
           <a:xfrm>
-            <a:off x="457200" y="274680"/>
-            <a:ext cx="8229240" cy="1142640"/>
+            <a:off x="457200" y="273600"/>
+            <a:ext cx="8229240" cy="1144800"/>
           </a:xfrm>
           <a:prstGeom prst="rect">
             <a:avLst/>
@@ -2154,11 +2091,11 @@
             <a:noAutofit/>
           </a:bodyPr>
           <a:p>
-            <a:endParaRPr b="0" lang="en-US" sz="1800" spc="-1" strike="noStrike">
-              <a:solidFill>
-                <a:srgbClr val="000000"/>
-              </a:solidFill>
-              <a:latin typeface="Calibri"/>
+            <a:pPr algn="ctr">
+              <a:buNone/>
+            </a:pPr>
+            <a:endParaRPr b="0" lang="en-US" sz="4400" spc="-1" strike="noStrike">
+              <a:latin typeface="Arial"/>
             </a:endParaRPr>
           </a:p>
         </p:txBody>
@@ -2175,8 +2112,8 @@
         </p:nvSpPr>
         <p:spPr>
           <a:xfrm>
-            <a:off x="457200" y="1600200"/>
-            <a:ext cx="4015800" cy="2158560"/>
+            <a:off x="457200" y="1604520"/>
+            <a:ext cx="4015800" cy="1896840"/>
           </a:xfrm>
           <a:prstGeom prst="rect">
             <a:avLst/>
@@ -2192,10 +2129,7 @@
           </a:bodyPr>
           <a:p>
             <a:endParaRPr b="0" lang="en-US" sz="3200" spc="-1" strike="noStrike">
-              <a:solidFill>
-                <a:srgbClr val="000000"/>
-              </a:solidFill>
-              <a:latin typeface="Calibri"/>
+              <a:latin typeface="Arial"/>
             </a:endParaRPr>
           </a:p>
         </p:txBody>
@@ -2212,8 +2146,8 @@
         </p:nvSpPr>
         <p:spPr>
           <a:xfrm>
-            <a:off x="4674240" y="1600200"/>
-            <a:ext cx="4015800" cy="2158560"/>
+            <a:off x="4674240" y="1604520"/>
+            <a:ext cx="4015800" cy="1896840"/>
           </a:xfrm>
           <a:prstGeom prst="rect">
             <a:avLst/>
@@ -2229,10 +2163,7 @@
           </a:bodyPr>
           <a:p>
             <a:endParaRPr b="0" lang="en-US" sz="3200" spc="-1" strike="noStrike">
-              <a:solidFill>
-                <a:srgbClr val="000000"/>
-              </a:solidFill>
-              <a:latin typeface="Calibri"/>
+              <a:latin typeface="Arial"/>
             </a:endParaRPr>
           </a:p>
         </p:txBody>
@@ -2249,8 +2180,8 @@
         </p:nvSpPr>
         <p:spPr>
           <a:xfrm>
-            <a:off x="457200" y="3964320"/>
-            <a:ext cx="8229240" cy="2158560"/>
+            <a:off x="457200" y="3682080"/>
+            <a:ext cx="8229240" cy="1896840"/>
           </a:xfrm>
           <a:prstGeom prst="rect">
             <a:avLst/>
@@ -2266,10 +2197,7 @@
           </a:bodyPr>
           <a:p>
             <a:endParaRPr b="0" lang="en-US" sz="3200" spc="-1" strike="noStrike">
-              <a:solidFill>
-                <a:srgbClr val="000000"/>
-              </a:solidFill>
-              <a:latin typeface="Calibri"/>
+              <a:latin typeface="Arial"/>
             </a:endParaRPr>
           </a:p>
         </p:txBody>
@@ -2281,7 +2209,7 @@
             <a:spLocks noGrp="1"/>
           </p:cNvSpPr>
           <p:nvPr>
-            <p:ph type="ftr" idx="2"/>
+            <p:ph type="ftr" idx="1"/>
           </p:nvPr>
         </p:nvSpPr>
         <p:spPr/>
@@ -2301,14 +2229,14 @@
             <a:spLocks noGrp="1"/>
           </p:cNvSpPr>
           <p:nvPr>
-            <p:ph type="sldNum" idx="3"/>
-          </p:nvPr>
-        </p:nvSpPr>
-        <p:spPr/>
-        <p:txBody>
-          <a:bodyPr/>
-          <a:p>
-            <a:fld id="{8F582F09-6D63-40E6-9C75-779ACACD2A65}" type="slidenum">
+            <p:ph type="sldNum" idx="2"/>
+          </p:nvPr>
+        </p:nvSpPr>
+        <p:spPr/>
+        <p:txBody>
+          <a:bodyPr/>
+          <a:p>
+            <a:fld id="{FC0E7AF2-F3FF-42B0-B33D-CB25928B4377}" type="slidenum">
               <a:t>&lt;#&gt;</a:t>
             </a:fld>
           </a:p>
@@ -2321,15 +2249,15 @@
             <a:spLocks noGrp="1"/>
           </p:cNvSpPr>
           <p:nvPr>
-            <p:ph type="dt" idx="1"/>
-          </p:nvPr>
-        </p:nvSpPr>
-        <p:spPr/>
-        <p:txBody>
-          <a:bodyPr/>
-          <a:p>
-            <a:r>
-              <a:rPr lang="en-HK"/>
+            <p:ph type="dt" idx="3"/>
+          </p:nvPr>
+        </p:nvSpPr>
+        <p:spPr/>
+        <p:txBody>
+          <a:bodyPr/>
+          <a:p>
+            <a:r>
+              <a:rPr lang="en-US"/>
               <a:t/>
             </a:r>
           </a:p>
@@ -2371,26 +2299,37 @@
             <a:spLocks noGrp="1"/>
           </p:cNvSpPr>
           <p:nvPr>
-            <p:ph type="title"/>
-          </p:nvPr>
-        </p:nvSpPr>
-        <p:spPr>
-          <a:xfrm>
-            <a:off x="457200" y="274680"/>
-            <a:ext cx="8229240" cy="1142640"/>
-          </a:xfrm>
-          <a:prstGeom prst="rect">
-            <a:avLst/>
-          </a:prstGeom>
-          <a:noFill/>
-          <a:ln w="0">
-            <a:noFill/>
-          </a:ln>
-        </p:spPr>
-        <p:txBody>
-          <a:bodyPr anchor="ctr">
+            <p:ph type="ftr" idx="1"/>
+          </p:nvPr>
+        </p:nvSpPr>
+        <p:spPr>
+          <a:xfrm>
+            <a:off x="3124080" y="6356520"/>
+            <a:ext cx="2894760" cy="364320"/>
+          </a:xfrm>
+          <a:prstGeom prst="rect">
+            <a:avLst/>
+          </a:prstGeom>
+          <a:noFill/>
+          <a:ln w="0">
+            <a:noFill/>
+          </a:ln>
+        </p:spPr>
+        <p:txBody>
+          <a:bodyPr lIns="90000" rIns="90000" tIns="45000" bIns="45000" anchor="ctr">
             <a:noAutofit/>
           </a:bodyPr>
+          <a:lstStyle>
+            <a:lvl1pPr algn="ctr">
+              <a:lnSpc>
+                <a:spcPct val="100000"/>
+              </a:lnSpc>
+              <a:buNone/>
+              <a:defRPr b="0" lang="en-HK" sz="1400" spc="-1" strike="noStrike">
+                <a:latin typeface="Times New Roman"/>
+              </a:defRPr>
+            </a:lvl1pPr>
+          </a:lstStyle>
           <a:p>
             <a:pPr algn="ctr">
               <a:lnSpc>
@@ -2399,311 +2338,12 @@
               <a:buNone/>
             </a:pPr>
             <a:r>
-              <a:rPr b="0" lang="en-US" sz="4400" spc="-1" strike="noStrike">
-                <a:solidFill>
-                  <a:srgbClr val="000000"/>
-                </a:solidFill>
-                <a:latin typeface="Calibri"/>
-              </a:rPr>
-              <a:t>Click to edit Master title style</a:t>
-            </a:r>
-            <a:endParaRPr b="0" lang="en-US" sz="4400" spc="-1" strike="noStrike">
-              <a:solidFill>
-                <a:srgbClr val="000000"/>
-              </a:solidFill>
-              <a:latin typeface="Calibri"/>
-            </a:endParaRPr>
-          </a:p>
-        </p:txBody>
-      </p:sp>
-      <p:sp>
-        <p:nvSpPr>
-          <p:cNvPr id="1" name="PlaceHolder 2"/>
-          <p:cNvSpPr>
-            <a:spLocks noGrp="1"/>
-          </p:cNvSpPr>
-          <p:nvPr>
-            <p:ph type="body"/>
-          </p:nvPr>
-        </p:nvSpPr>
-        <p:spPr>
-          <a:xfrm>
-            <a:off x="457200" y="1600200"/>
-            <a:ext cx="8229240" cy="4525560"/>
-          </a:xfrm>
-          <a:prstGeom prst="rect">
-            <a:avLst/>
-          </a:prstGeom>
-          <a:noFill/>
-          <a:ln w="0">
-            <a:noFill/>
-          </a:ln>
-        </p:spPr>
-        <p:txBody>
-          <a:bodyPr anchor="t">
-            <a:noAutofit/>
-          </a:bodyPr>
-          <a:p>
-            <a:pPr marL="343080" indent="-343080">
-              <a:lnSpc>
-                <a:spcPct val="100000"/>
-              </a:lnSpc>
-              <a:spcBef>
-                <a:spcPts val="641"/>
-              </a:spcBef>
-              <a:buClr>
-                <a:srgbClr val="000000"/>
-              </a:buClr>
-              <a:buFont typeface="Arial"/>
-              <a:buChar char="•"/>
-            </a:pPr>
-            <a:r>
-              <a:rPr b="0" lang="en-US" sz="3200" spc="-1" strike="noStrike">
-                <a:solidFill>
-                  <a:srgbClr val="000000"/>
-                </a:solidFill>
-                <a:latin typeface="Calibri"/>
-              </a:rPr>
-              <a:t>Click to edit Master text styles</a:t>
-            </a:r>
-            <a:endParaRPr b="0" lang="en-US" sz="3200" spc="-1" strike="noStrike">
-              <a:solidFill>
-                <a:srgbClr val="000000"/>
-              </a:solidFill>
-              <a:latin typeface="Calibri"/>
-            </a:endParaRPr>
-          </a:p>
-          <a:p>
-            <a:pPr lvl="1" marL="743040" indent="-285840">
-              <a:lnSpc>
-                <a:spcPct val="100000"/>
-              </a:lnSpc>
-              <a:spcBef>
-                <a:spcPts val="561"/>
-              </a:spcBef>
-              <a:buClr>
-                <a:srgbClr val="000000"/>
-              </a:buClr>
-              <a:buFont typeface="Arial"/>
-              <a:buChar char="–"/>
-            </a:pPr>
-            <a:r>
-              <a:rPr b="0" lang="en-US" sz="2800" spc="-1" strike="noStrike">
-                <a:solidFill>
-                  <a:srgbClr val="000000"/>
-                </a:solidFill>
-                <a:latin typeface="Calibri"/>
-              </a:rPr>
-              <a:t>Second level</a:t>
-            </a:r>
-            <a:endParaRPr b="0" lang="en-US" sz="2800" spc="-1" strike="noStrike">
-              <a:solidFill>
-                <a:srgbClr val="000000"/>
-              </a:solidFill>
-              <a:latin typeface="Calibri"/>
-            </a:endParaRPr>
-          </a:p>
-          <a:p>
-            <a:pPr lvl="2" marL="1143000" indent="-228600">
-              <a:lnSpc>
-                <a:spcPct val="100000"/>
-              </a:lnSpc>
-              <a:spcBef>
-                <a:spcPts val="479"/>
-              </a:spcBef>
-              <a:buClr>
-                <a:srgbClr val="000000"/>
-              </a:buClr>
-              <a:buFont typeface="Arial"/>
-              <a:buChar char="•"/>
-            </a:pPr>
-            <a:r>
-              <a:rPr b="0" lang="en-US" sz="2400" spc="-1" strike="noStrike">
-                <a:solidFill>
-                  <a:srgbClr val="000000"/>
-                </a:solidFill>
-                <a:latin typeface="Calibri"/>
-              </a:rPr>
-              <a:t>Third level</a:t>
-            </a:r>
-            <a:endParaRPr b="0" lang="en-US" sz="2400" spc="-1" strike="noStrike">
-              <a:solidFill>
-                <a:srgbClr val="000000"/>
-              </a:solidFill>
-              <a:latin typeface="Calibri"/>
-            </a:endParaRPr>
-          </a:p>
-          <a:p>
-            <a:pPr lvl="3" marL="1600200" indent="-228600">
-              <a:lnSpc>
-                <a:spcPct val="100000"/>
-              </a:lnSpc>
-              <a:spcBef>
-                <a:spcPts val="400"/>
-              </a:spcBef>
-              <a:buClr>
-                <a:srgbClr val="000000"/>
-              </a:buClr>
-              <a:buFont typeface="Arial"/>
-              <a:buChar char="–"/>
-            </a:pPr>
-            <a:r>
-              <a:rPr b="0" lang="en-US" sz="2000" spc="-1" strike="noStrike">
-                <a:solidFill>
-                  <a:srgbClr val="000000"/>
-                </a:solidFill>
-                <a:latin typeface="Calibri"/>
-              </a:rPr>
-              <a:t>Fourth level</a:t>
-            </a:r>
-            <a:endParaRPr b="0" lang="en-US" sz="2000" spc="-1" strike="noStrike">
-              <a:solidFill>
-                <a:srgbClr val="000000"/>
-              </a:solidFill>
-              <a:latin typeface="Calibri"/>
-            </a:endParaRPr>
-          </a:p>
-          <a:p>
-            <a:pPr lvl="4" marL="2057400" indent="-228600">
-              <a:lnSpc>
-                <a:spcPct val="100000"/>
-              </a:lnSpc>
-              <a:spcBef>
-                <a:spcPts val="400"/>
-              </a:spcBef>
-              <a:buClr>
-                <a:srgbClr val="000000"/>
-              </a:buClr>
-              <a:buFont typeface="Arial"/>
-              <a:buChar char="»"/>
-            </a:pPr>
-            <a:r>
-              <a:rPr b="0" lang="en-US" sz="2000" spc="-1" strike="noStrike">
-                <a:solidFill>
-                  <a:srgbClr val="000000"/>
-                </a:solidFill>
-                <a:latin typeface="Calibri"/>
-              </a:rPr>
-              <a:t>Fifth level</a:t>
-            </a:r>
-            <a:endParaRPr b="0" lang="en-US" sz="2000" spc="-1" strike="noStrike">
-              <a:solidFill>
-                <a:srgbClr val="000000"/>
-              </a:solidFill>
-              <a:latin typeface="Calibri"/>
-            </a:endParaRPr>
-          </a:p>
-        </p:txBody>
-      </p:sp>
-      <p:sp>
-        <p:nvSpPr>
-          <p:cNvPr id="2" name="PlaceHolder 3"/>
-          <p:cNvSpPr>
-            <a:spLocks noGrp="1"/>
-          </p:cNvSpPr>
-          <p:nvPr>
-            <p:ph type="dt" idx="1"/>
-          </p:nvPr>
-        </p:nvSpPr>
-        <p:spPr>
-          <a:xfrm>
-            <a:off x="457200" y="6356520"/>
-            <a:ext cx="2133360" cy="364680"/>
-          </a:xfrm>
-          <a:prstGeom prst="rect">
-            <a:avLst/>
-          </a:prstGeom>
-          <a:noFill/>
-          <a:ln w="0">
-            <a:noFill/>
-          </a:ln>
-        </p:spPr>
-        <p:txBody>
-          <a:bodyPr anchor="ctr">
-            <a:noAutofit/>
-          </a:bodyPr>
-          <a:lstStyle>
-            <a:lvl1pPr>
-              <a:lnSpc>
-                <a:spcPct val="100000"/>
-              </a:lnSpc>
-              <a:buNone/>
-              <a:defRPr b="0" lang="en-US" sz="1200" spc="-1" strike="noStrike">
-                <a:solidFill>
-                  <a:srgbClr val="8b8b8b"/>
-                </a:solidFill>
-                <a:latin typeface="Calibri"/>
-              </a:defRPr>
-            </a:lvl1pPr>
-          </a:lstStyle>
-          <a:p>
-            <a:pPr>
-              <a:lnSpc>
-                <a:spcPct val="100000"/>
-              </a:lnSpc>
-              <a:buNone/>
-            </a:pPr>
-            <a:r>
-              <a:rPr b="0" lang="en-US" sz="1200" spc="-1" strike="noStrike">
-                <a:solidFill>
-                  <a:srgbClr val="8b8b8b"/>
-                </a:solidFill>
-                <a:latin typeface="Calibri"/>
-              </a:rPr>
-              <a:t> </a:t>
-            </a:r>
-            <a:endParaRPr b="0" lang="en-HK" sz="1200" spc="-1" strike="noStrike">
-              <a:latin typeface="Times New Roman"/>
-            </a:endParaRPr>
-          </a:p>
-        </p:txBody>
-      </p:sp>
-      <p:sp>
-        <p:nvSpPr>
-          <p:cNvPr id="3" name="PlaceHolder 4"/>
-          <p:cNvSpPr>
-            <a:spLocks noGrp="1"/>
-          </p:cNvSpPr>
-          <p:nvPr>
-            <p:ph type="ftr" idx="2"/>
-          </p:nvPr>
-        </p:nvSpPr>
-        <p:spPr>
-          <a:xfrm>
-            <a:off x="3124080" y="6356520"/>
-            <a:ext cx="2895120" cy="364680"/>
-          </a:xfrm>
-          <a:prstGeom prst="rect">
-            <a:avLst/>
-          </a:prstGeom>
-          <a:noFill/>
-          <a:ln w="0">
-            <a:noFill/>
-          </a:ln>
-        </p:spPr>
-        <p:txBody>
-          <a:bodyPr anchor="ctr">
-            <a:noAutofit/>
-          </a:bodyPr>
-          <a:lstStyle>
-            <a:lvl1pPr algn="ctr">
-              <a:buNone/>
-              <a:defRPr b="0" lang="en-HK" sz="1400" spc="-1" strike="noStrike">
-                <a:latin typeface="Times New Roman"/>
-              </a:defRPr>
-            </a:lvl1pPr>
-          </a:lstStyle>
-          <a:p>
-            <a:pPr algn="ctr">
-              <a:buNone/>
-            </a:pPr>
-            <a:r>
               <a:rPr b="0" lang="en-HK" sz="1400" spc="-1" strike="noStrike">
                 <a:latin typeface="Times New Roman"/>
               </a:rPr>
-              <a:t> </a:t>
-            </a:r>
-            <a:endParaRPr b="0" lang="en-HK" sz="1400" spc="-1" strike="noStrike">
+              <a:t>&lt;footer&gt;</a:t>
+            </a:r>
+            <a:endParaRPr b="0" lang="en-US" sz="1400" spc="-1" strike="noStrike">
               <a:latin typeface="Times New Roman"/>
             </a:endParaRPr>
           </a:p>
@@ -2711,29 +2351,29 @@
       </p:sp>
       <p:sp>
         <p:nvSpPr>
-          <p:cNvPr id="4" name="PlaceHolder 5"/>
-          <p:cNvSpPr>
-            <a:spLocks noGrp="1"/>
-          </p:cNvSpPr>
-          <p:nvPr>
-            <p:ph type="sldNum" idx="3"/>
+          <p:cNvPr id="1" name="PlaceHolder 2"/>
+          <p:cNvSpPr>
+            <a:spLocks noGrp="1"/>
+          </p:cNvSpPr>
+          <p:nvPr>
+            <p:ph type="sldNum" idx="2"/>
           </p:nvPr>
         </p:nvSpPr>
         <p:spPr>
           <a:xfrm>
             <a:off x="6553080" y="6356520"/>
-            <a:ext cx="2133360" cy="364680"/>
-          </a:xfrm>
-          <a:prstGeom prst="rect">
-            <a:avLst/>
-          </a:prstGeom>
-          <a:noFill/>
-          <a:ln w="0">
-            <a:noFill/>
-          </a:ln>
-        </p:spPr>
-        <p:txBody>
-          <a:bodyPr anchor="ctr">
+            <a:ext cx="2133000" cy="364320"/>
+          </a:xfrm>
+          <a:prstGeom prst="rect">
+            <a:avLst/>
+          </a:prstGeom>
+          <a:noFill/>
+          <a:ln w="0">
+            <a:noFill/>
+          </a:ln>
+        </p:spPr>
+        <p:txBody>
+          <a:bodyPr lIns="90000" rIns="90000" tIns="45000" bIns="45000" anchor="ctr">
             <a:noAutofit/>
           </a:bodyPr>
           <a:lstStyle>
@@ -2757,7 +2397,7 @@
               </a:lnSpc>
               <a:buNone/>
             </a:pPr>
-            <a:fld id="{3DD6A253-256C-48A5-80CF-486BC05E8A37}" type="slidenum">
+            <a:fld id="{6FB54BAD-B01C-4611-A4C8-6DFAEDE9A5EA}" type="slidenum">
               <a:rPr b="0" lang="en-US" sz="1200" spc="-1" strike="noStrike">
                 <a:solidFill>
                   <a:srgbClr val="8b8b8b"/>
@@ -2766,8 +2406,281 @@
               </a:rPr>
               <a:t>&lt;number&gt;</a:t>
             </a:fld>
-            <a:endParaRPr b="0" lang="en-HK" sz="1200" spc="-1" strike="noStrike">
+            <a:endParaRPr b="0" lang="en-US" sz="1200" spc="-1" strike="noStrike">
               <a:latin typeface="Times New Roman"/>
+            </a:endParaRPr>
+          </a:p>
+        </p:txBody>
+      </p:sp>
+      <p:sp>
+        <p:nvSpPr>
+          <p:cNvPr id="2" name="PlaceHolder 3"/>
+          <p:cNvSpPr>
+            <a:spLocks noGrp="1"/>
+          </p:cNvSpPr>
+          <p:nvPr>
+            <p:ph type="dt" idx="3"/>
+          </p:nvPr>
+        </p:nvSpPr>
+        <p:spPr>
+          <a:xfrm>
+            <a:off x="457200" y="6356520"/>
+            <a:ext cx="2133000" cy="364320"/>
+          </a:xfrm>
+          <a:prstGeom prst="rect">
+            <a:avLst/>
+          </a:prstGeom>
+          <a:noFill/>
+          <a:ln w="0">
+            <a:noFill/>
+          </a:ln>
+        </p:spPr>
+        <p:txBody>
+          <a:bodyPr lIns="90000" rIns="90000" tIns="45000" bIns="45000" anchor="ctr">
+            <a:noAutofit/>
+          </a:bodyPr>
+          <a:lstStyle>
+            <a:lvl1pPr>
+              <a:defRPr b="0" lang="en-US" sz="1400" spc="-1" strike="noStrike">
+                <a:latin typeface="Times New Roman"/>
+              </a:defRPr>
+            </a:lvl1pPr>
+          </a:lstStyle>
+          <a:p>
+            <a:r>
+              <a:rPr b="0" lang="en-US" sz="1400" spc="-1" strike="noStrike">
+                <a:latin typeface="Times New Roman"/>
+              </a:rPr>
+              <a:t>&lt;date/time&gt;</a:t>
+            </a:r>
+            <a:endParaRPr b="0" lang="en-US" sz="1400" spc="-1" strike="noStrike">
+              <a:latin typeface="Times New Roman"/>
+            </a:endParaRPr>
+          </a:p>
+        </p:txBody>
+      </p:sp>
+      <p:sp>
+        <p:nvSpPr>
+          <p:cNvPr id="3" name="PlaceHolder 4"/>
+          <p:cNvSpPr>
+            <a:spLocks noGrp="1"/>
+          </p:cNvSpPr>
+          <p:nvPr>
+            <p:ph type="title"/>
+          </p:nvPr>
+        </p:nvSpPr>
+        <p:spPr>
+          <a:xfrm>
+            <a:off x="457200" y="273600"/>
+            <a:ext cx="8229240" cy="1144800"/>
+          </a:xfrm>
+          <a:prstGeom prst="rect">
+            <a:avLst/>
+          </a:prstGeom>
+          <a:noFill/>
+          <a:ln w="0">
+            <a:noFill/>
+          </a:ln>
+        </p:spPr>
+        <p:txBody>
+          <a:bodyPr lIns="0" rIns="0" tIns="0" bIns="0" anchor="ctr">
+            <a:noAutofit/>
+          </a:bodyPr>
+          <a:p>
+            <a:pPr algn="ctr">
+              <a:buNone/>
+            </a:pPr>
+            <a:r>
+              <a:rPr b="0" lang="en-US" sz="4400" spc="-1" strike="noStrike">
+                <a:latin typeface="Arial"/>
+              </a:rPr>
+              <a:t>Click to edit the title text format</a:t>
+            </a:r>
+            <a:endParaRPr b="0" lang="en-US" sz="4400" spc="-1" strike="noStrike">
+              <a:latin typeface="Arial"/>
+            </a:endParaRPr>
+          </a:p>
+        </p:txBody>
+      </p:sp>
+      <p:sp>
+        <p:nvSpPr>
+          <p:cNvPr id="4" name="PlaceHolder 5"/>
+          <p:cNvSpPr>
+            <a:spLocks noGrp="1"/>
+          </p:cNvSpPr>
+          <p:nvPr>
+            <p:ph type="body"/>
+          </p:nvPr>
+        </p:nvSpPr>
+        <p:spPr>
+          <a:xfrm>
+            <a:off x="457200" y="1604520"/>
+            <a:ext cx="8229240" cy="3977280"/>
+          </a:xfrm>
+          <a:prstGeom prst="rect">
+            <a:avLst/>
+          </a:prstGeom>
+          <a:noFill/>
+          <a:ln w="0">
+            <a:noFill/>
+          </a:ln>
+        </p:spPr>
+        <p:txBody>
+          <a:bodyPr lIns="0" rIns="0" tIns="0" bIns="0" anchor="t">
+            <a:normAutofit/>
+          </a:bodyPr>
+          <a:p>
+            <a:pPr marL="432000" indent="-324000">
+              <a:spcBef>
+                <a:spcPts val="1417"/>
+              </a:spcBef>
+              <a:buClr>
+                <a:srgbClr val="000000"/>
+              </a:buClr>
+              <a:buSzPct val="45000"/>
+              <a:buFont typeface="Wingdings" charset="2"/>
+              <a:buChar char=""/>
+            </a:pPr>
+            <a:r>
+              <a:rPr b="0" lang="en-US" sz="3200" spc="-1" strike="noStrike">
+                <a:latin typeface="Arial"/>
+              </a:rPr>
+              <a:t>Click to edit the outline text format</a:t>
+            </a:r>
+            <a:endParaRPr b="0" lang="en-US" sz="3200" spc="-1" strike="noStrike">
+              <a:latin typeface="Arial"/>
+            </a:endParaRPr>
+          </a:p>
+          <a:p>
+            <a:pPr lvl="1" marL="864000" indent="-324000">
+              <a:spcBef>
+                <a:spcPts val="1134"/>
+              </a:spcBef>
+              <a:buClr>
+                <a:srgbClr val="000000"/>
+              </a:buClr>
+              <a:buSzPct val="75000"/>
+              <a:buFont typeface="Symbol" charset="2"/>
+              <a:buChar char=""/>
+            </a:pPr>
+            <a:r>
+              <a:rPr b="0" lang="en-US" sz="2800" spc="-1" strike="noStrike">
+                <a:latin typeface="Arial"/>
+              </a:rPr>
+              <a:t>Second Outline Level</a:t>
+            </a:r>
+            <a:endParaRPr b="0" lang="en-US" sz="2800" spc="-1" strike="noStrike">
+              <a:latin typeface="Arial"/>
+            </a:endParaRPr>
+          </a:p>
+          <a:p>
+            <a:pPr lvl="2" marL="1296000" indent="-288000">
+              <a:spcBef>
+                <a:spcPts val="850"/>
+              </a:spcBef>
+              <a:buClr>
+                <a:srgbClr val="000000"/>
+              </a:buClr>
+              <a:buSzPct val="45000"/>
+              <a:buFont typeface="Wingdings" charset="2"/>
+              <a:buChar char=""/>
+            </a:pPr>
+            <a:r>
+              <a:rPr b="0" lang="en-US" sz="2400" spc="-1" strike="noStrike">
+                <a:latin typeface="Arial"/>
+              </a:rPr>
+              <a:t>Third Outline Level</a:t>
+            </a:r>
+            <a:endParaRPr b="0" lang="en-US" sz="2400" spc="-1" strike="noStrike">
+              <a:latin typeface="Arial"/>
+            </a:endParaRPr>
+          </a:p>
+          <a:p>
+            <a:pPr lvl="3" marL="1728000" indent="-216000">
+              <a:spcBef>
+                <a:spcPts val="567"/>
+              </a:spcBef>
+              <a:buClr>
+                <a:srgbClr val="000000"/>
+              </a:buClr>
+              <a:buSzPct val="75000"/>
+              <a:buFont typeface="Symbol" charset="2"/>
+              <a:buChar char=""/>
+            </a:pPr>
+            <a:r>
+              <a:rPr b="0" lang="en-US" sz="2000" spc="-1" strike="noStrike">
+                <a:latin typeface="Arial"/>
+              </a:rPr>
+              <a:t>Fourth Outline Level</a:t>
+            </a:r>
+            <a:endParaRPr b="0" lang="en-US" sz="2000" spc="-1" strike="noStrike">
+              <a:latin typeface="Arial"/>
+            </a:endParaRPr>
+          </a:p>
+          <a:p>
+            <a:pPr lvl="4" marL="2160000" indent="-216000">
+              <a:spcBef>
+                <a:spcPts val="283"/>
+              </a:spcBef>
+              <a:buClr>
+                <a:srgbClr val="000000"/>
+              </a:buClr>
+              <a:buSzPct val="45000"/>
+              <a:buFont typeface="Wingdings" charset="2"/>
+              <a:buChar char=""/>
+            </a:pPr>
+            <a:r>
+              <a:rPr b="0" lang="en-US" sz="2000" spc="-1" strike="noStrike">
+                <a:latin typeface="Arial"/>
+              </a:rPr>
+              <a:t>Fifth Outline Level</a:t>
+            </a:r>
+            <a:endParaRPr b="0" lang="en-US" sz="2000" spc="-1" strike="noStrike">
+              <a:latin typeface="Arial"/>
+            </a:endParaRPr>
+          </a:p>
+          <a:p>
+            <a:pPr lvl="5" marL="2592000" indent="-216000">
+              <a:spcBef>
+                <a:spcPts val="283"/>
+              </a:spcBef>
+              <a:buClr>
+                <a:srgbClr val="000000"/>
+              </a:buClr>
+              <a:buSzPct val="45000"/>
+              <a:buFont typeface="Wingdings" charset="2"/>
+              <a:buChar char=""/>
+            </a:pPr>
+            <a:r>
+              <a:rPr b="0" lang="en-US" sz="2000" spc="-1" strike="noStrike">
+                <a:latin typeface="Arial"/>
+              </a:rPr>
+              <a:t>Sixth Outline Level</a:t>
+            </a:r>
+            <a:endParaRPr b="0" lang="en-US" sz="2000" spc="-1" strike="noStrike">
+              <a:latin typeface="Arial"/>
+            </a:endParaRPr>
+          </a:p>
+          <a:p>
+            <a:pPr lvl="6" marL="3024000" indent="-216000">
+              <a:spcBef>
+                <a:spcPts val="283"/>
+              </a:spcBef>
+              <a:buClr>
+                <a:srgbClr val="000000"/>
+              </a:buClr>
+              <a:buSzPct val="45000"/>
+              <a:buFont typeface="Wingdings" charset="2"/>
+              <a:buChar char=""/>
+            </a:pPr>
+            <a:r>
+              <a:rPr b="0" lang="en-US" sz="2000" spc="-1" strike="noStrike">
+                <a:latin typeface="Arial"/>
+              </a:rPr>
+              <a:t>Seventh Outline Level</a:t>
+            </a:r>
+            <a:endParaRPr b="0" lang="en-US" sz="2000" spc="-1" strike="noStrike">
+              <a:latin typeface="Arial"/>
             </a:endParaRPr>
           </a:p>
         </p:txBody>
@@ -2798,9 +2711,8 @@
     <p:bg>
       <p:bgPr>
         <a:solidFill>
-          <a:srgbClr val="FF0000"/>
+          <a:srgbClr val="ff0000"/>
         </a:solidFill>
-        <a:effectLst/>
       </p:bgPr>
     </p:bg>
     <p:spTree>
@@ -2830,18 +2742,18 @@
         <p:spPr>
           <a:xfrm>
             <a:off x="457200" y="274680"/>
-            <a:ext cx="8229240" cy="1142640"/>
-          </a:xfrm>
-          <a:prstGeom prst="rect">
-            <a:avLst/>
-          </a:prstGeom>
-          <a:noFill/>
-          <a:ln w="0">
-            <a:noFill/>
-          </a:ln>
-        </p:spPr>
-        <p:txBody>
-          <a:bodyPr anchor="ctr">
+            <a:ext cx="8228880" cy="1142280"/>
+          </a:xfrm>
+          <a:prstGeom prst="rect">
+            <a:avLst/>
+          </a:prstGeom>
+          <a:noFill/>
+          <a:ln w="0">
+            <a:noFill/>
+          </a:ln>
+        </p:spPr>
+        <p:txBody>
+          <a:bodyPr lIns="90000" rIns="90000" tIns="45000" bIns="45000" anchor="ctr">
             <a:noAutofit/>
           </a:bodyPr>
           <a:p>
@@ -2861,10 +2773,7 @@
               <a:t>Neural Network</a:t>
             </a:r>
             <a:endParaRPr b="0" lang="en-US" sz="4400" spc="-1" strike="noStrike">
-              <a:solidFill>
-                <a:srgbClr val="000000"/>
-              </a:solidFill>
-              <a:latin typeface="Calibri"/>
+              <a:latin typeface="Arial"/>
             </a:endParaRPr>
           </a:p>
         </p:txBody>
@@ -2882,18 +2791,18 @@
         <p:spPr>
           <a:xfrm>
             <a:off x="457200" y="1600200"/>
-            <a:ext cx="8229240" cy="4525560"/>
-          </a:xfrm>
-          <a:prstGeom prst="rect">
-            <a:avLst/>
-          </a:prstGeom>
-          <a:noFill/>
-          <a:ln w="0">
-            <a:noFill/>
-          </a:ln>
-        </p:spPr>
-        <p:txBody>
-          <a:bodyPr anchor="t">
+            <a:ext cx="8228880" cy="4525200"/>
+          </a:xfrm>
+          <a:prstGeom prst="rect">
+            <a:avLst/>
+          </a:prstGeom>
+          <a:noFill/>
+          <a:ln w="0">
+            <a:noFill/>
+          </a:ln>
+        </p:spPr>
+        <p:txBody>
+          <a:bodyPr lIns="90000" rIns="90000" tIns="45000" bIns="45000" anchor="t">
             <a:noAutofit/>
           </a:bodyPr>
           <a:p>
@@ -2913,7 +2822,7 @@
             <a:r>
               <a:rPr b="0" lang="en-US" sz="1200" spc="-1" strike="noStrike">
                 <a:solidFill>
-                  <a:srgbClr val="FFA500"/>
+                  <a:srgbClr val="ffa500"/>
                 </a:solidFill>
                 <a:latin typeface="Calibri"/>
               </a:rPr>
@@ -2921,9 +2830,9 @@
             </a:r>
             <a:endParaRPr b="0" lang="en-US" sz="1200" spc="-1" strike="noStrike">
               <a:solidFill>
-                <a:srgbClr val="FFA500"/>
+                <a:srgbClr val="ffa500"/>
               </a:solidFill>
-              <a:latin typeface="Calibri"/>
+              <a:latin typeface="Arial"/>
             </a:endParaRPr>
           </a:p>
         </p:txBody>

</xml_diff>